<commit_message>
PowerPoint: Agenda erzählerisch invertiert — das Ereignis führt, die Kategorie tritt zurück
Auftraggeber-Befund: nach dem Entwichten wirkte die Agenda reizlos. Erzählerisch
ist ‹Worüber wir sprechen› die Kategorie, die vier Punkte sind das Ereignis.

- Vier Punkte (Rückblick/Zahlen/Einordnung/Ausblick) 13 → 26pt Deutlich: sie führen.
- Kategorie ‹Worüber wir sprechen› 26 → 18pt: tritt zurück.
- Unterzeilen 13 → 15pt (Leise, grau); Ordnungszahlen bleiben leise (18pt grau).

Der Platz war da (Beschluss Auftraggeber); die zentrierten Kästchen bleiben
ausgerichtet, keine Umbrüche.

Co-Authored-By: Claude Opus 4.8 <noreply@anthropic.com>
Claude-Session: https://claude.ai/code/session_01Y5E7rmod1QoMupwrH2cPDi
</commit_message>
<xml_diff>
--- a/assets/templates/GoetheanumVorlageA4.pptx
+++ b/assets/templates/GoetheanumVorlageA4.pptx
@@ -10737,7 +10737,7 @@
               <a:buNone/>
             </a:pPr>
             <a:r>
-              <a:rPr lang="en-US" sz="2600" dirty="0">
+              <a:rPr lang="en-US" sz="1800" dirty="0">
                 <a:solidFill>
                   <a:srgbClr val="1A1A1A"/>
                 </a:solidFill>
@@ -10818,7 +10818,7 @@
               <a:buNone/>
             </a:pPr>
             <a:r>
-              <a:rPr lang="en-US" sz="1300" dirty="0">
+              <a:rPr lang="en-US" sz="2600" dirty="0">
                 <a:solidFill>
                   <a:srgbClr val="1A1A1A"/>
                 </a:solidFill>
@@ -10838,7 +10838,7 @@
               <a:buNone/>
             </a:pPr>
             <a:r>
-              <a:rPr lang="en-US" sz="1300" dirty="0">
+              <a:rPr lang="en-US" sz="1500" dirty="0">
                 <a:solidFill>
                   <a:srgbClr val="6B7480"/>
                 </a:solidFill>
@@ -10919,7 +10919,7 @@
               <a:buNone/>
             </a:pPr>
             <a:r>
-              <a:rPr lang="en-US" sz="1300" dirty="0">
+              <a:rPr lang="en-US" sz="2600" dirty="0">
                 <a:solidFill>
                   <a:srgbClr val="1A1A1A"/>
                 </a:solidFill>
@@ -10939,7 +10939,7 @@
               <a:buNone/>
             </a:pPr>
             <a:r>
-              <a:rPr lang="en-US" sz="1300" dirty="0">
+              <a:rPr lang="en-US" sz="1500" dirty="0">
                 <a:solidFill>
                   <a:srgbClr val="6B7480"/>
                 </a:solidFill>
@@ -11020,7 +11020,7 @@
               <a:buNone/>
             </a:pPr>
             <a:r>
-              <a:rPr lang="en-US" sz="1300" dirty="0">
+              <a:rPr lang="en-US" sz="2600" dirty="0">
                 <a:solidFill>
                   <a:srgbClr val="1A1A1A"/>
                 </a:solidFill>
@@ -11040,7 +11040,7 @@
               <a:buNone/>
             </a:pPr>
             <a:r>
-              <a:rPr lang="en-US" sz="1300" dirty="0">
+              <a:rPr lang="en-US" sz="1500" dirty="0">
                 <a:solidFill>
                   <a:srgbClr val="6B7480"/>
                 </a:solidFill>
@@ -11121,7 +11121,7 @@
               <a:buNone/>
             </a:pPr>
             <a:r>
-              <a:rPr lang="en-US" sz="1300" dirty="0">
+              <a:rPr lang="en-US" sz="2600" dirty="0">
                 <a:solidFill>
                   <a:srgbClr val="1A1A1A"/>
                 </a:solidFill>
@@ -11141,7 +11141,7 @@
               <a:buNone/>
             </a:pPr>
             <a:r>
-              <a:rPr lang="en-US" sz="1300" dirty="0">
+              <a:rPr lang="en-US" sz="1500" dirty="0">
                 <a:solidFill>
                   <a:srgbClr val="6B7480"/>
                 </a:solidFill>

</xml_diff>

<commit_message>
PowerPoint: Laut aus dem Funktionssatz (Folie 3) nehmen — ‹Goetheanum Icons› in Leise
Am echten PP sperrt der Laut-Schnitt zeitweise stark (nur Laut, kommt/geht,
sehr weit) — Font-Daten sind nachweislich sauber (Gewicht 400, kein Fett-Flag,
GPOS/Kerning wie Klar), also ein Umgebungs-Effekt (sehr wahrscheinlich ein
doppelt installierter alter Laut-Schnitt in der Schriftsammlung).

Damit der Erklärsatz nicht ‹zerrissen› wirkt: ‹Goetheanum Icons› auf Folie 3
von Laut auf Leise — die ‹› markieren den Namen bereits (G03), keine Betonung
nötig. Das einzige verbleibende Laut steht bewusst im Spezimen (Folie 2), wo der
Schnitt vorgeführt WIRD; das rendert korrekt, sobald der Doppel-/Cache-Font
bereinigt ist.

Co-Authored-By: Claude Opus 4.8 <noreply@anthropic.com>
Claude-Session: https://claude.ai/code/session_01Y5E7rmod1QoMupwrH2cPDi
</commit_message>
<xml_diff>
--- a/assets/templates/GoetheanumVorlageA4.pptx
+++ b/assets/templates/GoetheanumVorlageA4.pptx
@@ -8601,9 +8601,9 @@
                 <a:solidFill>
                   <a:srgbClr val="6B7480"/>
                 </a:solidFill>
-                <a:latin typeface="Goetheanum Schrift Laut" pitchFamily="34" charset="0"/>
-                <a:ea typeface="Goetheanum Schrift Laut" pitchFamily="34" charset="-122"/>
-                <a:cs typeface="Goetheanum Schrift Laut" pitchFamily="34" charset="-120"/>
+                <a:latin typeface="Goetheanum Schrift Leise" pitchFamily="34" charset="0"/>
+                <a:ea typeface="Goetheanum Schrift Leise" pitchFamily="34" charset="-122"/>
+                <a:cs typeface="Goetheanum Schrift Leise" pitchFamily="34" charset="-120"/>
               </a:rPr>
               <a:t>‹Goetheanum Icons›</a:t>
             </a:r>

</xml_diff>

<commit_message>
PowerPoint-Vorlage: zwei belegte Regelverstösse behoben (G22, B02)
Folie 9 (G22): Kicker »Kapitel 01« → »Kapitel 1« — führende Null getilgt,
jetzt konsistent mit Folie 6/7 (»Kapitel 1«).

Folie 10 (B02): goldene Kennzahl »3,2 Mio« war #EBB565 auf der Kachel
#EEF4FB = 1,67:1 (weit unter 4,5:1). Auf das Haus-Token --gold-ink
(#8A6728) gehoben = 4,68:1 — gold bleibt, Kontrast hält.

Vorlage und Komplettpaket deterministisch neu gepackt (gleiche
Schriften.html / LIESMICH wie die retarget-Pipeline).

Co-Authored-By: Claude Opus 4.8 <noreply@anthropic.com>
Claude-Session: https://claude.ai/code/session_01Y5E7rmod1QoMupwrH2cPDi
</commit_message>
<xml_diff>
--- a/assets/templates/GoetheanumVorlageA4.pptx
+++ b/assets/templates/GoetheanumVorlageA4.pptx
@@ -4801,7 +4801,7 @@
             <a:r>
               <a:rPr lang="en-US" sz="2600" dirty="0">
                 <a:solidFill>
-                  <a:srgbClr val="EBB565"/>
+                  <a:srgbClr val="8A6728"/>
                 </a:solidFill>
                 <a:latin typeface="Goetheanum Schrift Deutlich" pitchFamily="34" charset="0"/>
                 <a:ea typeface="Goetheanum Schrift Deutlich" pitchFamily="34" charset="-122"/>
@@ -12565,7 +12565,7 @@
                 <a:ea typeface="Goetheanum Schrift" pitchFamily="34" charset="-122"/>
                 <a:cs typeface="Goetheanum Schrift" pitchFamily="34" charset="-120"/>
               </a:rPr>
-              <a:t>Kapitel 01</a:t>
+              <a:t>Kapitel 1</a:t>
             </a:r>
             <a:endParaRPr lang="en-US" sz="1300" dirty="0"/>
           </a:p>

</xml_diff>

<commit_message>
PowerPoint-Vorlage: Kontraste, System-Gold und Datums-Platzhalter geregelt (#472)
Alle im Review gefundenen Regelverstösse behoben:
- B02: Fusszeile/Kontakt/Seitenzahl auf Blau, Geisterziffer, Kennzahl-Gold, Diagramm-Gold auf gerechnet konforme Werte.
- G22: Kicker »Kapitel 01«→»Kapitel 1«, Datum »00.00.2026«→»TT.MM.JJJJ«.
- Fundament: neues Token --on-accent-muted (Design-System 1.9.5).
Master-Seitenzahl auf Weiss + Theme-Swatches bewusst offen (separater Marken-/Weiss-Entscheid).
</commit_message>
<xml_diff>
--- a/assets/templates/GoetheanumVorlageA4.pptx
+++ b/assets/templates/GoetheanumVorlageA4.pptx
@@ -238,7 +238,7 @@
           </c:tx>
           <c:spPr>
             <a:solidFill>
-              <a:srgbClr val="EBB565"/>
+              <a:srgbClr val="94702E"/>
             </a:solidFill>
             <a:effectLst/>
           </c:spPr>
@@ -2357,7 +2357,7 @@
               <a:buNone/>
               <a:defRPr lang="en-US" sz="1300" dirty="0">
                 <a:solidFill>
-                  <a:srgbClr val="9CC3EC"/>
+                  <a:srgbClr val="CCDFF1"/>
                 </a:solidFill>
                 <a:latin typeface="Goetheanum Schrift" pitchFamily="34" charset="0"/>
                 <a:ea typeface="Goetheanum Schrift" pitchFamily="34" charset="-122"/>
@@ -2372,13 +2372,13 @@
             <a:r>
               <a:rPr lang="en-US" sz="1300" dirty="0">
                 <a:solidFill>
-                  <a:srgbClr val="9CC3EC"/>
-                </a:solidFill>
-                <a:latin typeface="Goetheanum Schrift" pitchFamily="34" charset="0"/>
-                <a:ea typeface="Goetheanum Schrift" pitchFamily="34" charset="-122"/>
-                <a:cs typeface="Goetheanum Schrift" pitchFamily="34" charset="-120"/>
-              </a:rPr>
-              <a:t>Vorname Name · Bereich · 00.00.2026</a:t>
+                  <a:srgbClr val="CCDFF1"/>
+                </a:solidFill>
+                <a:latin typeface="Goetheanum Schrift" pitchFamily="34" charset="0"/>
+                <a:ea typeface="Goetheanum Schrift" pitchFamily="34" charset="-122"/>
+                <a:cs typeface="Goetheanum Schrift" pitchFamily="34" charset="-120"/>
+              </a:rPr>
+              <a:t>Vorname Name · Bereich · TT.MM.JJJJ</a:t>
             </a:r>
             <a:endParaRPr lang="en-US" sz="1300" dirty="0"/>
           </a:p>
@@ -2467,13 +2467,13 @@
             <a:r>
               <a:rPr lang="en-US" sz="900" dirty="0">
                 <a:solidFill>
-                  <a:srgbClr val="9CC3EC"/>
-                </a:solidFill>
-                <a:latin typeface="Goetheanum Schrift" pitchFamily="34" charset="0"/>
-                <a:ea typeface="Goetheanum Schrift" pitchFamily="34" charset="-122"/>
-                <a:cs typeface="Goetheanum Schrift" pitchFamily="34" charset="-120"/>
-              </a:rPr>
-              <a:t>Titel der Präsentation · 00.00.2026 ·</a:t>
+                  <a:srgbClr val="CCDFF1"/>
+                </a:solidFill>
+                <a:latin typeface="Goetheanum Schrift" pitchFamily="34" charset="0"/>
+                <a:ea typeface="Goetheanum Schrift" pitchFamily="34" charset="-122"/>
+                <a:cs typeface="Goetheanum Schrift" pitchFamily="34" charset="-120"/>
+              </a:rPr>
+              <a:t>Titel der Präsentation · TT.MM.JJJJ ·</a:t>
             </a:r>
             <a:endParaRPr lang="en-US" sz="900" dirty="0"/>
           </a:p>
@@ -2505,7 +2505,7 @@
               <a:buNone/>
               <a:defRPr i="1" lang="en-US" sz="5000" dirty="0">
                 <a:solidFill>
-                  <a:srgbClr val="4D90D6"/>
+                  <a:srgbClr val="93BCE7"/>
                 </a:solidFill>
                 <a:latin typeface="Goetheanum Schrift" pitchFamily="34" charset="0"/>
                 <a:ea typeface="Goetheanum Schrift" pitchFamily="34" charset="-122"/>
@@ -2520,7 +2520,7 @@
             <a:r>
               <a:rPr i="1" lang="en-US" sz="5000" dirty="0">
                 <a:solidFill>
-                  <a:srgbClr val="4D90D6"/>
+                  <a:srgbClr val="93BCE7"/>
                 </a:solidFill>
                 <a:latin typeface="Goetheanum Schrift" pitchFamily="34" charset="0"/>
                 <a:ea typeface="Goetheanum Schrift" pitchFamily="34" charset="-122"/>
@@ -2668,7 +2668,7 @@
             <a:lvl1pPr>
               <a:defRPr sz="900">
                 <a:solidFill>
-                  <a:srgbClr val="9CC3EC"/>
+                  <a:srgbClr val="CCDFF1"/>
                 </a:solidFill>
                 <a:latin typeface="Goetheanum Schrift"/>
                 <a:ea typeface="Goetheanum Schrift"/>
@@ -2775,7 +2775,7 @@
                 <a:ea typeface="Goetheanum Schrift" pitchFamily="34" charset="-122"/>
                 <a:cs typeface="Goetheanum Schrift" pitchFamily="34" charset="-120"/>
               </a:rPr>
-              <a:t>Titel der Präsentation · 00.00.2026 ·</a:t>
+              <a:t>Titel der Präsentation · TT.MM.JJJJ ·</a:t>
             </a:r>
             <a:endParaRPr lang="en-US" sz="900" dirty="0"/>
           </a:p>
@@ -3024,7 +3024,7 @@
                 <a:ea typeface="Goetheanum Schrift" pitchFamily="34" charset="-122"/>
                 <a:cs typeface="Goetheanum Schrift" pitchFamily="34" charset="-120"/>
               </a:rPr>
-              <a:t>Titel der Präsentation · 00.00.2026 ·</a:t>
+              <a:t>Titel der Präsentation · TT.MM.JJJJ ·</a:t>
             </a:r>
             <a:endParaRPr lang="en-US" sz="900" dirty="0"/>
           </a:p>
@@ -3273,7 +3273,7 @@
                 <a:ea typeface="Goetheanum Schrift" pitchFamily="34" charset="-122"/>
                 <a:cs typeface="Goetheanum Schrift" pitchFamily="34" charset="-120"/>
               </a:rPr>
-              <a:t>Titel der Präsentation · 00.00.2026 ·</a:t>
+              <a:t>Titel der Präsentation · TT.MM.JJJJ ·</a:t>
             </a:r>
             <a:endParaRPr lang="en-US" sz="900" dirty="0"/>
           </a:p>
@@ -3488,7 +3488,7 @@
                 <a:ea typeface="Goetheanum Schrift" pitchFamily="34" charset="-122"/>
                 <a:cs typeface="Goetheanum Schrift" pitchFamily="34" charset="-120"/>
               </a:rPr>
-              <a:t>Titel der Präsentation · 00.00.2026 ·</a:t>
+              <a:t>Titel der Präsentation · TT.MM.JJJJ ·</a:t>
             </a:r>
             <a:endParaRPr lang="en-US" sz="900" dirty="0"/>
           </a:p>
@@ -4333,13 +4333,13 @@
             <a:r>
               <a:rPr lang="en-US" sz="1300" dirty="0">
                 <a:solidFill>
-                  <a:srgbClr val="9CC3EC"/>
-                </a:solidFill>
-                <a:latin typeface="Goetheanum Schrift" pitchFamily="34" charset="0"/>
-                <a:ea typeface="Goetheanum Schrift" pitchFamily="34" charset="-122"/>
-                <a:cs typeface="Goetheanum Schrift" pitchFamily="34" charset="-120"/>
-              </a:rPr>
-              <a:t>Vorname Name · Bereich · 00.00.2026</a:t>
+                  <a:srgbClr val="CCDFF1"/>
+                </a:solidFill>
+                <a:latin typeface="Goetheanum Schrift" pitchFamily="34" charset="0"/>
+                <a:ea typeface="Goetheanum Schrift" pitchFamily="34" charset="-122"/>
+                <a:cs typeface="Goetheanum Schrift" pitchFamily="34" charset="-120"/>
+              </a:rPr>
+              <a:t>Vorname Name · Bereich · TT.MM.JJJJ</a:t>
             </a:r>
             <a:endParaRPr lang="en-US" sz="1300" dirty="0"/>
           </a:p>
@@ -4801,7 +4801,7 @@
             <a:r>
               <a:rPr lang="en-US" sz="2600" dirty="0">
                 <a:solidFill>
-                  <a:srgbClr val="EBB565"/>
+                  <a:srgbClr val="8A6728"/>
                 </a:solidFill>
                 <a:latin typeface="Goetheanum Schrift Deutlich" pitchFamily="34" charset="0"/>
                 <a:ea typeface="Goetheanum Schrift Deutlich" pitchFamily="34" charset="-122"/>
@@ -7461,7 +7461,7 @@
             <a:r>
               <a:rPr lang="en-US" sz="1300" dirty="0">
                 <a:solidFill>
-                  <a:srgbClr val="9CC3EC"/>
+                  <a:srgbClr val="CCDFF1"/>
                 </a:solidFill>
                 <a:latin typeface="Goetheanum Schrift" pitchFamily="34" charset="0"/>
                 <a:ea typeface="Goetheanum Schrift" pitchFamily="34" charset="-122"/>
@@ -11257,7 +11257,7 @@
             <a:r>
               <a:rPr i="1" lang="en-US" sz="5000" dirty="0">
                 <a:solidFill>
-                  <a:srgbClr val="4D90D6"/>
+                  <a:srgbClr val="93BCE7"/>
                 </a:solidFill>
                 <a:latin typeface="Goetheanum Schrift" pitchFamily="34" charset="0"/>
                 <a:ea typeface="Goetheanum Schrift" pitchFamily="34" charset="-122"/>
@@ -11381,7 +11381,7 @@
             <a:lvl1pPr>
               <a:defRPr sz="900">
                 <a:solidFill>
-                  <a:srgbClr val="9CC3EC"/>
+                  <a:srgbClr val="CCDFF1"/>
                 </a:solidFill>
                 <a:latin typeface="Goetheanum Schrift"/>
                 <a:ea typeface="Goetheanum Schrift"/>
@@ -12565,7 +12565,7 @@
                 <a:ea typeface="Goetheanum Schrift" pitchFamily="34" charset="-122"/>
                 <a:cs typeface="Goetheanum Schrift" pitchFamily="34" charset="-120"/>
               </a:rPr>
-              <a:t>Kapitel 01</a:t>
+              <a:t>Kapitel 1</a:t>
             </a:r>
             <a:endParaRPr lang="en-US" sz="1300" dirty="0"/>
           </a:p>

</xml_diff>

<commit_message>
Zweite Feintypografie-Folie + Lesemass auf ‹Bild und Text›
Mehr Regeln, weiter verteilt.

Neue Folie 5 ‹Noch feinere Zeichen› (nach der ersten Feintypografie-Folie):
sechs weitere Regeln je am grossen Beispiel —
  und so weiter … · Ja – oder Nein? · 9–17 Uhr · z. B. sonntags · Grösse · Silbentrennung
für Auslassung (G19), Gedankenstrich und Bis-Strich (G18), schmales
geschütztes Leerzeichen in Abkürzungen (G20), Schweizer Schreibung/de-CH
(G24) und aktive Silbentrennung (G12). Gleiche Fusszeile aufs Regelwerk.

Eingestreut auf Folie ‹Bild und Text›: das Lesemass benannt —
»seine Spaltenbreite – rund 62 Zeichen –« (G10), dort wo die Folie ohnehin
von der Spaltenbreite spricht.

Sauber als 17. Teil registriert (Content-Types, presentation.rels,
sldIdLst Position 5), XML wohlgeformt.

Co-Authored-By: Claude Opus 4.8 <noreply@anthropic.com>
Claude-Session: https://claude.ai/code/session_01Y5E7rmod1QoMupwrH2cPDi
</commit_message>
<xml_diff>
--- a/assets/templates/GoetheanumVorlageA4.pptx
+++ b/assets/templates/GoetheanumVorlageA4.pptx
@@ -9,6 +9,7 @@
     <p:sldId id="257" r:id="rId3"/>
     <p:sldId id="258" r:id="rId4"/>
     <p:sldId id="271" r:id="rId22"/>
+    <p:sldId id="272" r:id="rId23"/>
     <p:sldId id="259" r:id="rId5"/>
     <p:sldId id="260" r:id="rId6"/>
     <p:sldId id="261" r:id="rId7"/>
@@ -7940,6 +7941,464 @@
 </p:sld>
 </file>
 
+<file path=ppt/slides/slide17.xml><?xml version="1.0" encoding="utf-8"?>
+<p:sld xmlns:a="http://schemas.openxmlformats.org/drawingml/2006/main" xmlns:r="http://schemas.openxmlformats.org/officeDocument/2006/relationships" xmlns:p="http://schemas.openxmlformats.org/presentationml/2006/main">
+  <p:cSld name="GOE Feintypografie 2">
+    <p:spTree>
+      <p:nvGrpSpPr>
+        <p:cNvPr id="1" name=""/>
+        <p:cNvGrpSpPr/>
+        <p:nvPr/>
+      </p:nvGrpSpPr>
+      <p:grpSpPr>
+        <a:xfrm>
+          <a:off x="0" y="0"/>
+          <a:ext cx="0" cy="0"/>
+          <a:chOff x="0" y="0"/>
+          <a:chExt cx="0" cy="0"/>
+        </a:xfrm>
+      </p:grpSpPr>
+      <p:sp>
+        <p:nvSpPr>
+          <p:cNvPr id="2" name="Kicker"/>
+          <p:cNvSpPr/>
+          <p:nvPr/>
+        </p:nvSpPr>
+        <p:spPr>
+          <a:xfrm>
+            <a:off x="548640" y="1143000"/>
+            <a:ext cx="4572000" cy="274320"/>
+          </a:xfrm>
+          <a:prstGeom prst="rect">
+            <a:avLst/>
+          </a:prstGeom>
+          <a:noFill/>
+          <a:ln/>
+        </p:spPr>
+        <p:txBody>
+          <a:bodyPr wrap="square" lIns="0" tIns="0" rIns="0" bIns="0" rtlCol="0" anchor="t"/>
+          <a:lstStyle/>
+          <a:p>
+            <a:pPr indent="0" marL="0">
+              <a:buNone/>
+            </a:pPr>
+            <a:r>
+              <a:rPr lang="de-CH" sz="1300" dirty="0">
+                <a:solidFill>
+                  <a:srgbClr val="005EB8"/>
+                </a:solidFill>
+                <a:latin typeface="Goetheanum Schrift" pitchFamily="34" charset="0"/>
+                <a:ea typeface="Goetheanum Schrift" pitchFamily="34" charset="-122"/>
+                <a:cs typeface="Goetheanum Schrift" pitchFamily="34" charset="-120"/>
+              </a:rPr>
+              <a:t>Vorlage</a:t>
+            </a:r>
+          </a:p>
+        </p:txBody>
+      </p:sp>
+      <p:sp>
+        <p:nvSpPr>
+          <p:cNvPr id="3" name="Titel"/>
+          <p:cNvSpPr/>
+          <p:nvPr/>
+        </p:nvSpPr>
+        <p:spPr>
+          <a:xfrm>
+            <a:off x="548640" y="1463040"/>
+            <a:ext cx="9592056" cy="594360"/>
+          </a:xfrm>
+          <a:prstGeom prst="rect">
+            <a:avLst/>
+          </a:prstGeom>
+          <a:noFill/>
+          <a:ln/>
+        </p:spPr>
+        <p:txBody>
+          <a:bodyPr wrap="square" lIns="0" tIns="0" rIns="0" bIns="0" rtlCol="0" anchor="t"/>
+          <a:lstStyle/>
+          <a:p>
+            <a:pPr indent="0" marL="0">
+              <a:buNone/>
+            </a:pPr>
+            <a:r>
+              <a:rPr lang="de-CH" sz="2600" dirty="0">
+                <a:solidFill>
+                  <a:srgbClr val="1A1A1A"/>
+                </a:solidFill>
+                <a:latin typeface="Goetheanum Schrift Deutlich" pitchFamily="34" charset="0"/>
+                <a:ea typeface="Goetheanum Schrift Deutlich" pitchFamily="34" charset="-122"/>
+                <a:cs typeface="Goetheanum Schrift Deutlich" pitchFamily="34" charset="-120"/>
+              </a:rPr>
+              <a:t>Noch feinere Zeichen</a:t>
+            </a:r>
+          </a:p>
+        </p:txBody>
+      </p:sp>
+      <p:sp>
+        <p:nvSpPr>
+          <p:cNvPr id="4" name="Lede"/>
+          <p:cNvSpPr/>
+          <p:nvPr/>
+        </p:nvSpPr>
+        <p:spPr>
+          <a:xfrm>
+            <a:off x="548640" y="2286000"/>
+            <a:ext cx="9592056" cy="320040"/>
+          </a:xfrm>
+          <a:prstGeom prst="rect">
+            <a:avLst/>
+          </a:prstGeom>
+          <a:noFill/>
+          <a:ln/>
+        </p:spPr>
+        <p:txBody>
+          <a:bodyPr wrap="square" lIns="0" tIns="0" rIns="0" bIns="0" rtlCol="0" anchor="t"/>
+          <a:lstStyle/>
+          <a:p>
+            <a:pPr indent="0" marL="0">
+              <a:buNone/>
+            </a:pPr>
+            <a:r>
+              <a:rPr lang="de-CH" sz="1300" dirty="0">
+                <a:solidFill>
+                  <a:srgbClr val="6B7480"/>
+                </a:solidFill>
+                <a:latin typeface="Goetheanum Schrift" pitchFamily="34" charset="0"/>
+                <a:ea typeface="Goetheanum Schrift" pitchFamily="34" charset="-122"/>
+                <a:cs typeface="Goetheanum Schrift" pitchFamily="34" charset="-120"/>
+              </a:rPr>
+              <a:t>Striche mit Namen, Punkte mit Mass – kleine Unterschiede, grosse Ruhe.</a:t>
+            </a:r>
+          </a:p>
+        </p:txBody>
+      </p:sp>
+      <p:sp>
+        <p:nvSpPr>
+          <p:cNvPr id="5" name="BeispieleLinks"/>
+          <p:cNvSpPr/>
+          <p:nvPr/>
+        </p:nvSpPr>
+        <p:spPr>
+          <a:xfrm>
+            <a:off x="548640" y="3060000"/>
+            <a:ext cx="4680000" cy="3960000"/>
+          </a:xfrm>
+          <a:prstGeom prst="rect">
+            <a:avLst/>
+          </a:prstGeom>
+          <a:noFill/>
+          <a:ln/>
+        </p:spPr>
+        <p:txBody>
+          <a:bodyPr wrap="square" lIns="0" tIns="0" rIns="0" bIns="0" rtlCol="0" anchor="t"/>
+          <a:lstStyle/>
+          <a:p>
+            <a:pPr indent="0" marL="0">
+              <a:buNone/>
+            </a:pPr>
+            <a:r>
+              <a:rPr lang="de-CH" sz="2400" dirty="0">
+                <a:solidFill>
+                  <a:srgbClr val="1A1A1A"/>
+                </a:solidFill>
+                <a:latin typeface="Goetheanum Schrift" pitchFamily="34" charset="0"/>
+                <a:ea typeface="Goetheanum Schrift" pitchFamily="34" charset="-122"/>
+                <a:cs typeface="Goetheanum Schrift" pitchFamily="34" charset="-120"/>
+              </a:rPr>
+              <a:t>und so weiter …</a:t>
+            </a:r>
+          </a:p>
+          <a:p>
+            <a:pPr indent="0" marL="0">
+              <a:spcBef>
+                <a:spcPts val="200"/>
+              </a:spcBef>
+              <a:buNone/>
+            </a:pPr>
+            <a:r>
+              <a:rPr lang="de-CH" sz="1000" dirty="0">
+                <a:solidFill>
+                  <a:srgbClr val="6B7480"/>
+                </a:solidFill>
+                <a:latin typeface="Goetheanum Schrift" pitchFamily="34" charset="0"/>
+                <a:ea typeface="Goetheanum Schrift" pitchFamily="34" charset="-122"/>
+                <a:cs typeface="Goetheanum Schrift" pitchFamily="34" charset="-120"/>
+              </a:rPr>
+              <a:t>Auslassung: ein Zeichen …, nicht drei Punkte</a:t>
+            </a:r>
+          </a:p>
+          <a:p>
+            <a:pPr indent="0" marL="0">
+              <a:spcBef>
+                <a:spcPts val="2000"/>
+              </a:spcBef>
+              <a:buNone/>
+            </a:pPr>
+            <a:r>
+              <a:rPr lang="de-CH" sz="2400" dirty="0">
+                <a:solidFill>
+                  <a:srgbClr val="1A1A1A"/>
+                </a:solidFill>
+                <a:latin typeface="Goetheanum Schrift" pitchFamily="34" charset="0"/>
+                <a:ea typeface="Goetheanum Schrift" pitchFamily="34" charset="-122"/>
+                <a:cs typeface="Goetheanum Schrift" pitchFamily="34" charset="-120"/>
+              </a:rPr>
+              <a:t>Ja – oder Nein?</a:t>
+            </a:r>
+          </a:p>
+          <a:p>
+            <a:pPr indent="0" marL="0">
+              <a:spcBef>
+                <a:spcPts val="200"/>
+              </a:spcBef>
+              <a:buNone/>
+            </a:pPr>
+            <a:r>
+              <a:rPr lang="de-CH" sz="1000" dirty="0">
+                <a:solidFill>
+                  <a:srgbClr val="6B7480"/>
+                </a:solidFill>
+                <a:latin typeface="Goetheanum Schrift" pitchFamily="34" charset="0"/>
+                <a:ea typeface="Goetheanum Schrift" pitchFamily="34" charset="-122"/>
+                <a:cs typeface="Goetheanum Schrift" pitchFamily="34" charset="-120"/>
+              </a:rPr>
+              <a:t>Gedankenstrich: Halbgeviert – mit Spatien</a:t>
+            </a:r>
+          </a:p>
+          <a:p>
+            <a:pPr indent="0" marL="0">
+              <a:spcBef>
+                <a:spcPts val="2000"/>
+              </a:spcBef>
+              <a:buNone/>
+            </a:pPr>
+            <a:r>
+              <a:rPr lang="de-CH" sz="2400" dirty="0">
+                <a:solidFill>
+                  <a:srgbClr val="1A1A1A"/>
+                </a:solidFill>
+                <a:latin typeface="Goetheanum Schrift" pitchFamily="34" charset="0"/>
+                <a:ea typeface="Goetheanum Schrift" pitchFamily="34" charset="-122"/>
+                <a:cs typeface="Goetheanum Schrift" pitchFamily="34" charset="-120"/>
+              </a:rPr>
+              <a:t>9–17 Uhr</a:t>
+            </a:r>
+          </a:p>
+          <a:p>
+            <a:pPr indent="0" marL="0">
+              <a:spcBef>
+                <a:spcPts val="200"/>
+              </a:spcBef>
+              <a:buNone/>
+            </a:pPr>
+            <a:r>
+              <a:rPr lang="de-CH" sz="1000" dirty="0">
+                <a:solidFill>
+                  <a:srgbClr val="6B7480"/>
+                </a:solidFill>
+                <a:latin typeface="Goetheanum Schrift" pitchFamily="34" charset="0"/>
+                <a:ea typeface="Goetheanum Schrift" pitchFamily="34" charset="-122"/>
+                <a:cs typeface="Goetheanum Schrift" pitchFamily="34" charset="-120"/>
+              </a:rPr>
+              <a:t>Bis-Strich: Halbgeviert, ohne Spatien</a:t>
+            </a:r>
+          </a:p>
+        </p:txBody>
+      </p:sp>
+      <p:sp>
+        <p:nvSpPr>
+          <p:cNvPr id="6" name="BeispieleRechts"/>
+          <p:cNvSpPr/>
+          <p:nvPr/>
+        </p:nvSpPr>
+        <p:spPr>
+          <a:xfrm>
+            <a:off x="5688640" y="3060000"/>
+            <a:ext cx="4680000" cy="3960000"/>
+          </a:xfrm>
+          <a:prstGeom prst="rect">
+            <a:avLst/>
+          </a:prstGeom>
+          <a:noFill/>
+          <a:ln/>
+        </p:spPr>
+        <p:txBody>
+          <a:bodyPr wrap="square" lIns="0" tIns="0" rIns="0" bIns="0" rtlCol="0" anchor="t"/>
+          <a:lstStyle/>
+          <a:p>
+            <a:pPr indent="0" marL="0">
+              <a:buNone/>
+            </a:pPr>
+            <a:r>
+              <a:rPr lang="de-CH" sz="2400" dirty="0">
+                <a:solidFill>
+                  <a:srgbClr val="1A1A1A"/>
+                </a:solidFill>
+                <a:latin typeface="Goetheanum Schrift" pitchFamily="34" charset="0"/>
+                <a:ea typeface="Goetheanum Schrift" pitchFamily="34" charset="-122"/>
+                <a:cs typeface="Goetheanum Schrift" pitchFamily="34" charset="-120"/>
+              </a:rPr>
+              <a:t>z. B. sonntags</a:t>
+            </a:r>
+          </a:p>
+          <a:p>
+            <a:pPr indent="0" marL="0">
+              <a:spcBef>
+                <a:spcPts val="200"/>
+              </a:spcBef>
+              <a:buNone/>
+            </a:pPr>
+            <a:r>
+              <a:rPr lang="de-CH" sz="1000" dirty="0">
+                <a:solidFill>
+                  <a:srgbClr val="6B7480"/>
+                </a:solidFill>
+                <a:latin typeface="Goetheanum Schrift" pitchFamily="34" charset="0"/>
+                <a:ea typeface="Goetheanum Schrift" pitchFamily="34" charset="-122"/>
+                <a:cs typeface="Goetheanum Schrift" pitchFamily="34" charset="-120"/>
+              </a:rPr>
+              <a:t>schmales geschütztes Leerzeichen, auch in Abkürzungen</a:t>
+            </a:r>
+          </a:p>
+          <a:p>
+            <a:pPr indent="0" marL="0">
+              <a:spcBef>
+                <a:spcPts val="2000"/>
+              </a:spcBef>
+              <a:buNone/>
+            </a:pPr>
+            <a:r>
+              <a:rPr lang="de-CH" sz="2400" dirty="0">
+                <a:solidFill>
+                  <a:srgbClr val="1A1A1A"/>
+                </a:solidFill>
+                <a:latin typeface="Goetheanum Schrift" pitchFamily="34" charset="0"/>
+                <a:ea typeface="Goetheanum Schrift" pitchFamily="34" charset="-122"/>
+                <a:cs typeface="Goetheanum Schrift" pitchFamily="34" charset="-120"/>
+              </a:rPr>
+              <a:t>Grösse</a:t>
+            </a:r>
+          </a:p>
+          <a:p>
+            <a:pPr indent="0" marL="0">
+              <a:spcBef>
+                <a:spcPts val="200"/>
+              </a:spcBef>
+              <a:buNone/>
+            </a:pPr>
+            <a:r>
+              <a:rPr lang="de-CH" sz="1000" dirty="0">
+                <a:solidFill>
+                  <a:srgbClr val="6B7480"/>
+                </a:solidFill>
+                <a:latin typeface="Goetheanum Schrift" pitchFamily="34" charset="0"/>
+                <a:ea typeface="Goetheanum Schrift" pitchFamily="34" charset="-122"/>
+                <a:cs typeface="Goetheanum Schrift" pitchFamily="34" charset="-120"/>
+              </a:rPr>
+              <a:t>Schweizer Schreibung: ss statt ß</a:t>
+            </a:r>
+          </a:p>
+          <a:p>
+            <a:pPr indent="0" marL="0">
+              <a:spcBef>
+                <a:spcPts val="2000"/>
+              </a:spcBef>
+              <a:buNone/>
+            </a:pPr>
+            <a:r>
+              <a:rPr lang="de-CH" sz="2400" dirty="0">
+                <a:solidFill>
+                  <a:srgbClr val="1A1A1A"/>
+                </a:solidFill>
+                <a:latin typeface="Goetheanum Schrift" pitchFamily="34" charset="0"/>
+                <a:ea typeface="Goetheanum Schrift" pitchFamily="34" charset="-122"/>
+                <a:cs typeface="Goetheanum Schrift" pitchFamily="34" charset="-120"/>
+              </a:rPr>
+              <a:t>Silbentrennung</a:t>
+            </a:r>
+          </a:p>
+          <a:p>
+            <a:pPr indent="0" marL="0">
+              <a:spcBef>
+                <a:spcPts val="200"/>
+              </a:spcBef>
+              <a:buNone/>
+            </a:pPr>
+            <a:r>
+              <a:rPr lang="de-CH" sz="1000" dirty="0">
+                <a:solidFill>
+                  <a:srgbClr val="6B7480"/>
+                </a:solidFill>
+                <a:latin typeface="Goetheanum Schrift" pitchFamily="34" charset="0"/>
+                <a:ea typeface="Goetheanum Schrift" pitchFamily="34" charset="-122"/>
+                <a:cs typeface="Goetheanum Schrift" pitchFamily="34" charset="-120"/>
+              </a:rPr>
+              <a:t>aktiv gesetzt – für einen ruhigen Rand</a:t>
+            </a:r>
+          </a:p>
+        </p:txBody>
+      </p:sp>
+      <p:sp>
+        <p:nvSpPr>
+          <p:cNvPr id="7" name="Regelwerk-Link"/>
+          <p:cNvSpPr/>
+          <p:nvPr/>
+        </p:nvSpPr>
+        <p:spPr>
+          <a:xfrm>
+            <a:off x="548640" y="5040000"/>
+            <a:ext cx="9592056" cy="274320"/>
+          </a:xfrm>
+          <a:prstGeom prst="rect">
+            <a:avLst/>
+          </a:prstGeom>
+          <a:noFill/>
+          <a:ln/>
+        </p:spPr>
+        <p:txBody>
+          <a:bodyPr wrap="square" lIns="0" tIns="0" rIns="0" bIns="0" rtlCol="0" anchor="t"/>
+          <a:lstStyle/>
+          <a:p>
+            <a:pPr indent="0" marL="0">
+              <a:buNone/>
+            </a:pPr>
+            <a:r>
+              <a:rPr lang="de-CH" sz="1000" dirty="0">
+                <a:solidFill>
+                  <a:srgbClr val="6B7480"/>
+                </a:solidFill>
+                <a:latin typeface="Goetheanum Schrift" pitchFamily="34" charset="0"/>
+                <a:ea typeface="Goetheanum Schrift" pitchFamily="34" charset="-122"/>
+                <a:cs typeface="Goetheanum Schrift" pitchFamily="34" charset="-120"/>
+              </a:rPr>
+              <a:t>Das ganze Regelwerk: </a:t>
+            </a:r>
+            <a:r>
+              <a:rPr lang="de-CH" sz="1000" dirty="0">
+                <a:solidFill>
+                  <a:srgbClr val="005EB8"/>
+                </a:solidFill>
+                <a:latin typeface="Goetheanum Schrift" pitchFamily="34" charset="0"/>
+                <a:ea typeface="Goetheanum Schrift" pitchFamily="34" charset="-122"/>
+                <a:cs typeface="Goetheanum Schrift" pitchFamily="34" charset="-120"/>
+                <a:hlinkClick r:id="rId2" invalidUrl="" action="" tgtFrame="" tooltip="" history="1" highlightClick="0" endSnd="0">
+                  <a:extLst>
+                    <a:ext uri="{A12FA001-AC4F-418D-AE19-62706E023703}">
+                      <ahyp:hlinkClr xmlns:ahyp="http://schemas.microsoft.com/office/drawing/2018/hyperlinkcolor" val="tx"/>
+                    </a:ext>
+                  </a:extLst>
+                </a:hlinkClick>
+              </a:rPr>
+              <a:t>werkzeuge.goetheanum.ch/typografie</a:t>
+            </a:r>
+          </a:p>
+        </p:txBody>
+      </p:sp>
+    </p:spTree>
+  </p:cSld>
+</p:sld>
+</file>
+
 <file path=ppt/slides/slide2.xml><?xml version="1.0" encoding="utf-8"?>
 <p:sld xmlns:a="http://schemas.openxmlformats.org/drawingml/2006/main" xmlns:r="http://schemas.openxmlformats.org/officeDocument/2006/relationships" xmlns:p="http://schemas.openxmlformats.org/presentationml/2006/main">
   <p:cSld name="Slide 2">
@@ -13237,7 +13696,7 @@
                 <a:ea typeface="Goetheanum Schrift" pitchFamily="34" charset="-122"/>
                 <a:cs typeface="Goetheanum Schrift" pitchFamily="34" charset="-120"/>
               </a:rPr>
-              <a:t>Der Text behält seine Spaltenbreite</a:t>
+              <a:t>Der Text behält seine Spaltenbreite – rund 62 Zeichen –</a:t>
             </a:r>
             <a:endParaRPr lang="en-US" sz="1300" dirty="0"/>
           </a:p>

</xml_diff>

<commit_message>
Gütesiegel: die Vorlage lehrt die gemeinsame Sprache (#473)
Die Platzhalterpräsi wird zum Lehrstück: zwei anschauliche Feintypografie-Folien
(‹Die kleinen Zeichen›, ‹Noch feinere Zeichen›), Regeln eingestreut auf bestehende
Folien (Einfachauszeichnung, Lesemass, Minus/Leerzeichen, tabellarische Ziffern,
Korrektur Deutlich statt Laut), ein Gütesiegel-Kästchen (gesichert ↔ Goodwill) und
die frühere Kontrast-/Gold-/Datums-Runde. Tool-Seite: schlankes Panel am Lesemass,
verlinkt aufs Regelwerk. Alle Regeln mit korrektem Zeichensatz (…, –, −, U+202F, ‹›).
</commit_message>
<xml_diff>
--- a/assets/templates/GoetheanumVorlageA4.pptx
+++ b/assets/templates/GoetheanumVorlageA4.pptx
@@ -8,6 +8,8 @@
     <p:sldId id="256" r:id="rId2"/>
     <p:sldId id="257" r:id="rId3"/>
     <p:sldId id="258" r:id="rId4"/>
+    <p:sldId id="271" r:id="rId22"/>
+    <p:sldId id="272" r:id="rId23"/>
     <p:sldId id="259" r:id="rId5"/>
     <p:sldId id="260" r:id="rId6"/>
     <p:sldId id="261" r:id="rId7"/>
@@ -4885,7 +4887,7 @@
                 <a:ea typeface="Goetheanum Schrift" pitchFamily="34" charset="-122"/>
                 <a:cs typeface="Goetheanum Schrift" pitchFamily="34" charset="-120"/>
               </a:rPr>
-              <a:t>Musterzahlen, beim Ausfüllen ersetzen.</a:t>
+              <a:t>Musterzahlen ersetzen. −2,1 % trägt ein echtes Minus, 12,4 Mio ein schmales Leerzeichen.</a:t>
             </a:r>
             <a:endParaRPr lang="en-US" sz="1300" dirty="0"/>
           </a:p>
@@ -6458,7 +6460,7 @@
                 <a:ea typeface="Goetheanum Schrift" pitchFamily="34" charset="-122"/>
                 <a:cs typeface="Goetheanum Schrift" pitchFamily="34" charset="-120"/>
               </a:rPr>
-              <a:t>Angaben in Tausend CHF, Musterzahlen.</a:t>
+              <a:t>Angaben in Tausend CHF. Ziffern tabellarisch und rechtsbündig; 11 690 gruppiert.</a:t>
             </a:r>
             <a:endParaRPr lang="en-US" sz="900" dirty="0"/>
           </a:p>
@@ -7481,6 +7483,922 @@
 </p:sld>
 </file>
 
+<file path=ppt/slides/slide16.xml><?xml version="1.0" encoding="utf-8"?>
+<p:sld xmlns:a="http://schemas.openxmlformats.org/drawingml/2006/main" xmlns:r="http://schemas.openxmlformats.org/officeDocument/2006/relationships" xmlns:p="http://schemas.openxmlformats.org/presentationml/2006/main">
+  <p:cSld name="GOE Feintypografie">
+    <p:spTree>
+      <p:nvGrpSpPr>
+        <p:cNvPr id="1" name=""/>
+        <p:cNvGrpSpPr/>
+        <p:nvPr/>
+      </p:nvGrpSpPr>
+      <p:grpSpPr>
+        <a:xfrm>
+          <a:off x="0" y="0"/>
+          <a:ext cx="0" cy="0"/>
+          <a:chOff x="0" y="0"/>
+          <a:chExt cx="0" cy="0"/>
+        </a:xfrm>
+      </p:grpSpPr>
+      <p:sp>
+        <p:nvSpPr>
+          <p:cNvPr id="2" name="Kicker"/>
+          <p:cNvSpPr/>
+          <p:nvPr/>
+        </p:nvSpPr>
+        <p:spPr>
+          <a:xfrm>
+            <a:off x="548640" y="1143000"/>
+            <a:ext cx="4572000" cy="274320"/>
+          </a:xfrm>
+          <a:prstGeom prst="rect">
+            <a:avLst/>
+          </a:prstGeom>
+          <a:noFill/>
+          <a:ln/>
+        </p:spPr>
+        <p:txBody>
+          <a:bodyPr wrap="square" lIns="0" tIns="0" rIns="0" bIns="0" rtlCol="0" anchor="t"/>
+          <a:lstStyle/>
+          <a:p>
+            <a:pPr indent="0" marL="0">
+              <a:buNone/>
+            </a:pPr>
+            <a:r>
+              <a:rPr lang="de-CH" sz="1300" dirty="0">
+                <a:solidFill>
+                  <a:srgbClr val="005EB8"/>
+                </a:solidFill>
+                <a:latin typeface="Goetheanum Schrift" pitchFamily="34" charset="0"/>
+                <a:ea typeface="Goetheanum Schrift" pitchFamily="34" charset="-122"/>
+                <a:cs typeface="Goetheanum Schrift" pitchFamily="34" charset="-120"/>
+              </a:rPr>
+              <a:t>Vorlage</a:t>
+            </a:r>
+          </a:p>
+        </p:txBody>
+      </p:sp>
+      <p:sp>
+        <p:nvSpPr>
+          <p:cNvPr id="3" name="Titel"/>
+          <p:cNvSpPr/>
+          <p:nvPr/>
+        </p:nvSpPr>
+        <p:spPr>
+          <a:xfrm>
+            <a:off x="548640" y="1463040"/>
+            <a:ext cx="9592056" cy="594360"/>
+          </a:xfrm>
+          <a:prstGeom prst="rect">
+            <a:avLst/>
+          </a:prstGeom>
+          <a:noFill/>
+          <a:ln/>
+        </p:spPr>
+        <p:txBody>
+          <a:bodyPr wrap="square" lIns="0" tIns="0" rIns="0" bIns="0" rtlCol="0" anchor="t"/>
+          <a:lstStyle/>
+          <a:p>
+            <a:pPr indent="0" marL="0">
+              <a:buNone/>
+            </a:pPr>
+            <a:r>
+              <a:rPr lang="de-CH" sz="2600" dirty="0">
+                <a:solidFill>
+                  <a:srgbClr val="1A1A1A"/>
+                </a:solidFill>
+                <a:latin typeface="Goetheanum Schrift Deutlich" pitchFamily="34" charset="0"/>
+                <a:ea typeface="Goetheanum Schrift Deutlich" pitchFamily="34" charset="-122"/>
+                <a:cs typeface="Goetheanum Schrift Deutlich" pitchFamily="34" charset="-120"/>
+              </a:rPr>
+              <a:t>Die kleinen Zeichen</a:t>
+            </a:r>
+          </a:p>
+        </p:txBody>
+      </p:sp>
+      <p:sp>
+        <p:nvSpPr>
+          <p:cNvPr id="4" name="Lede"/>
+          <p:cNvSpPr/>
+          <p:nvPr/>
+        </p:nvSpPr>
+        <p:spPr>
+          <a:xfrm>
+            <a:off x="548640" y="2286000"/>
+            <a:ext cx="9592056" cy="320040"/>
+          </a:xfrm>
+          <a:prstGeom prst="rect">
+            <a:avLst/>
+          </a:prstGeom>
+          <a:noFill/>
+          <a:ln/>
+        </p:spPr>
+        <p:txBody>
+          <a:bodyPr wrap="square" lIns="0" tIns="0" rIns="0" bIns="0" rtlCol="0" anchor="t"/>
+          <a:lstStyle/>
+          <a:p>
+            <a:pPr indent="0" marL="0">
+              <a:buNone/>
+            </a:pPr>
+            <a:r>
+              <a:rPr lang="de-CH" sz="1300" dirty="0">
+                <a:solidFill>
+                  <a:srgbClr val="6B7480"/>
+                </a:solidFill>
+                <a:latin typeface="Goetheanum Schrift" pitchFamily="34" charset="0"/>
+                <a:ea typeface="Goetheanum Schrift" pitchFamily="34" charset="-122"/>
+                <a:cs typeface="Goetheanum Schrift" pitchFamily="34" charset="-120"/>
+              </a:rPr>
+              <a:t>Klein, aber sie tragen die Sorgfalt – was PowerPoint nicht erzwingt.</a:t>
+            </a:r>
+          </a:p>
+        </p:txBody>
+      </p:sp>
+      <p:sp>
+        <p:nvSpPr>
+          <p:cNvPr id="5" name="BeispieleLinks"/>
+          <p:cNvSpPr/>
+          <p:nvPr/>
+        </p:nvSpPr>
+        <p:spPr>
+          <a:xfrm>
+            <a:off x="548640" y="3060000"/>
+            <a:ext cx="4680000" cy="3960000"/>
+          </a:xfrm>
+          <a:prstGeom prst="rect">
+            <a:avLst/>
+          </a:prstGeom>
+          <a:noFill/>
+          <a:ln/>
+        </p:spPr>
+        <p:txBody>
+          <a:bodyPr wrap="square" lIns="0" tIns="0" rIns="0" bIns="0" rtlCol="0" anchor="t"/>
+          <a:lstStyle/>
+          <a:p>
+            <a:pPr indent="0" marL="0">
+              <a:buNone/>
+            </a:pPr>
+            <a:r>
+              <a:rPr lang="de-CH" sz="2400" dirty="0">
+                <a:solidFill>
+                  <a:srgbClr val="1A1A1A"/>
+                </a:solidFill>
+                <a:latin typeface="Goetheanum Schrift" pitchFamily="34" charset="0"/>
+                <a:ea typeface="Goetheanum Schrift" pitchFamily="34" charset="-122"/>
+                <a:cs typeface="Goetheanum Schrift" pitchFamily="34" charset="-120"/>
+              </a:rPr>
+              <a:t>‹Zitat›</a:t>
+            </a:r>
+          </a:p>
+          <a:p>
+            <a:pPr indent="0" marL="0">
+              <a:spcBef>
+                <a:spcPts val="200"/>
+              </a:spcBef>
+              <a:buNone/>
+            </a:pPr>
+            <a:r>
+              <a:rPr lang="de-CH" sz="1000" dirty="0">
+                <a:solidFill>
+                  <a:srgbClr val="6B7480"/>
+                </a:solidFill>
+                <a:latin typeface="Goetheanum Schrift" pitchFamily="34" charset="0"/>
+                <a:ea typeface="Goetheanum Schrift" pitchFamily="34" charset="-122"/>
+                <a:cs typeface="Goetheanum Schrift" pitchFamily="34" charset="-120"/>
+              </a:rPr>
+              <a:t>einfache Guillemets ‹…› für Anführungen</a:t>
+            </a:r>
+          </a:p>
+          <a:p>
+            <a:pPr indent="0" marL="0">
+              <a:spcBef>
+                <a:spcPts val="2000"/>
+              </a:spcBef>
+              <a:buNone/>
+            </a:pPr>
+            <a:r>
+              <a:rPr lang="de-CH" sz="2400" dirty="0">
+                <a:solidFill>
+                  <a:srgbClr val="1A1A1A"/>
+                </a:solidFill>
+                <a:latin typeface="Goetheanum Schrift" pitchFamily="34" charset="0"/>
+                <a:ea typeface="Goetheanum Schrift" pitchFamily="34" charset="-122"/>
+                <a:cs typeface="Goetheanum Schrift" pitchFamily="34" charset="-120"/>
+              </a:rPr>
+              <a:t>−2,1 %</a:t>
+            </a:r>
+          </a:p>
+          <a:p>
+            <a:pPr indent="0" marL="0">
+              <a:spcBef>
+                <a:spcPts val="200"/>
+              </a:spcBef>
+              <a:buNone/>
+            </a:pPr>
+            <a:r>
+              <a:rPr lang="de-CH" sz="1000" dirty="0">
+                <a:solidFill>
+                  <a:srgbClr val="6B7480"/>
+                </a:solidFill>
+                <a:latin typeface="Goetheanum Schrift" pitchFamily="34" charset="0"/>
+                <a:ea typeface="Goetheanum Schrift" pitchFamily="34" charset="-122"/>
+                <a:cs typeface="Goetheanum Schrift" pitchFamily="34" charset="-120"/>
+              </a:rPr>
+              <a:t>echtes Minus −, kein Bindestrich</a:t>
+            </a:r>
+          </a:p>
+          <a:p>
+            <a:pPr indent="0" marL="0">
+              <a:spcBef>
+                <a:spcPts val="2000"/>
+              </a:spcBef>
+              <a:buNone/>
+            </a:pPr>
+            <a:r>
+              <a:rPr lang="de-CH" sz="2400" dirty="0">
+                <a:solidFill>
+                  <a:srgbClr val="1A1A1A"/>
+                </a:solidFill>
+                <a:latin typeface="Goetheanum Schrift" pitchFamily="34" charset="0"/>
+                <a:ea typeface="Goetheanum Schrift" pitchFamily="34" charset="-122"/>
+                <a:cs typeface="Goetheanum Schrift" pitchFamily="34" charset="-120"/>
+              </a:rPr>
+              <a:t>Kapitel 1</a:t>
+            </a:r>
+          </a:p>
+          <a:p>
+            <a:pPr indent="0" marL="0">
+              <a:spcBef>
+                <a:spcPts val="200"/>
+              </a:spcBef>
+              <a:buNone/>
+            </a:pPr>
+            <a:r>
+              <a:rPr lang="de-CH" sz="1000" dirty="0">
+                <a:solidFill>
+                  <a:srgbClr val="6B7480"/>
+                </a:solidFill>
+                <a:latin typeface="Goetheanum Schrift" pitchFamily="34" charset="0"/>
+                <a:ea typeface="Goetheanum Schrift" pitchFamily="34" charset="-122"/>
+                <a:cs typeface="Goetheanum Schrift" pitchFamily="34" charset="-120"/>
+              </a:rPr>
+              <a:t>keine führenden Nullen – nicht ‹01›</a:t>
+            </a:r>
+          </a:p>
+        </p:txBody>
+      </p:sp>
+      <p:sp>
+        <p:nvSpPr>
+          <p:cNvPr id="6" name="BeispieleRechts"/>
+          <p:cNvSpPr/>
+          <p:nvPr/>
+        </p:nvSpPr>
+        <p:spPr>
+          <a:xfrm>
+            <a:off x="5688640" y="3060000"/>
+            <a:ext cx="4680000" cy="3960000"/>
+          </a:xfrm>
+          <a:prstGeom prst="rect">
+            <a:avLst/>
+          </a:prstGeom>
+          <a:noFill/>
+          <a:ln/>
+        </p:spPr>
+        <p:txBody>
+          <a:bodyPr wrap="square" lIns="0" tIns="0" rIns="0" bIns="0" rtlCol="0" anchor="t"/>
+          <a:lstStyle/>
+          <a:p>
+            <a:pPr indent="0" marL="0">
+              <a:buNone/>
+            </a:pPr>
+            <a:r>
+              <a:rPr lang="de-CH" sz="2400" dirty="0">
+                <a:solidFill>
+                  <a:srgbClr val="1A1A1A"/>
+                </a:solidFill>
+                <a:latin typeface="Goetheanum Schrift" pitchFamily="34" charset="0"/>
+                <a:ea typeface="Goetheanum Schrift" pitchFamily="34" charset="-122"/>
+                <a:cs typeface="Goetheanum Schrift" pitchFamily="34" charset="-120"/>
+              </a:rPr>
+              <a:t>12,4 Mio</a:t>
+            </a:r>
+          </a:p>
+          <a:p>
+            <a:pPr indent="0" marL="0">
+              <a:spcBef>
+                <a:spcPts val="200"/>
+              </a:spcBef>
+              <a:buNone/>
+            </a:pPr>
+            <a:r>
+              <a:rPr lang="de-CH" sz="1000" dirty="0">
+                <a:solidFill>
+                  <a:srgbClr val="6B7480"/>
+                </a:solidFill>
+                <a:latin typeface="Goetheanum Schrift" pitchFamily="34" charset="0"/>
+                <a:ea typeface="Goetheanum Schrift" pitchFamily="34" charset="-122"/>
+                <a:cs typeface="Goetheanum Schrift" pitchFamily="34" charset="-120"/>
+              </a:rPr>
+              <a:t>Zahl und Einheit zusammen: schmales geschütztes Leerzeichen</a:t>
+            </a:r>
+          </a:p>
+          <a:p>
+            <a:pPr indent="0" marL="0">
+              <a:spcBef>
+                <a:spcPts val="2000"/>
+              </a:spcBef>
+              <a:buNone/>
+            </a:pPr>
+            <a:r>
+              <a:rPr lang="de-CH" sz="2400" dirty="0">
+                <a:solidFill>
+                  <a:srgbClr val="1A1A1A"/>
+                </a:solidFill>
+                <a:latin typeface="Goetheanum Schrift" pitchFamily="34" charset="0"/>
+                <a:ea typeface="Goetheanum Schrift" pitchFamily="34" charset="-122"/>
+                <a:cs typeface="Goetheanum Schrift" pitchFamily="34" charset="-120"/>
+              </a:rPr>
+              <a:t>11 690</a:t>
+            </a:r>
+          </a:p>
+          <a:p>
+            <a:pPr indent="0" marL="0">
+              <a:spcBef>
+                <a:spcPts val="200"/>
+              </a:spcBef>
+              <a:buNone/>
+            </a:pPr>
+            <a:r>
+              <a:rPr lang="de-CH" sz="1000" dirty="0">
+                <a:solidFill>
+                  <a:srgbClr val="6B7480"/>
+                </a:solidFill>
+                <a:latin typeface="Goetheanum Schrift" pitchFamily="34" charset="0"/>
+                <a:ea typeface="Goetheanum Schrift" pitchFamily="34" charset="-122"/>
+                <a:cs typeface="Goetheanum Schrift" pitchFamily="34" charset="-120"/>
+              </a:rPr>
+              <a:t>Ziffern tabellarisch und rechtsbündig, Tausender gruppiert</a:t>
+            </a:r>
+          </a:p>
+          <a:p>
+            <a:pPr indent="0" marL="0">
+              <a:spcBef>
+                <a:spcPts val="2000"/>
+              </a:spcBef>
+              <a:buNone/>
+            </a:pPr>
+            <a:r>
+              <a:rPr lang="de-CH" sz="2400" b="1" dirty="0">
+                <a:solidFill>
+                  <a:srgbClr val="1A1A1A"/>
+                </a:solidFill>
+                <a:latin typeface="Goetheanum Schrift" pitchFamily="34" charset="0"/>
+                <a:ea typeface="Goetheanum Schrift" pitchFamily="34" charset="-122"/>
+                <a:cs typeface="Goetheanum Schrift" pitchFamily="34" charset="-120"/>
+              </a:rPr>
+              <a:t>wichtig</a:t>
+            </a:r>
+          </a:p>
+          <a:p>
+            <a:pPr indent="0" marL="0">
+              <a:spcBef>
+                <a:spcPts val="200"/>
+              </a:spcBef>
+              <a:buNone/>
+            </a:pPr>
+            <a:r>
+              <a:rPr lang="de-CH" sz="1000" dirty="0">
+                <a:solidFill>
+                  <a:srgbClr val="6B7480"/>
+                </a:solidFill>
+                <a:latin typeface="Goetheanum Schrift" pitchFamily="34" charset="0"/>
+                <a:ea typeface="Goetheanum Schrift" pitchFamily="34" charset="-122"/>
+                <a:cs typeface="Goetheanum Schrift" pitchFamily="34" charset="-120"/>
+              </a:rPr>
+              <a:t>Einfachauszeichnung: ein Merkmal genügt – Laut, nie Versal</a:t>
+            </a:r>
+          </a:p>
+        </p:txBody>
+      </p:sp>
+      <p:sp>
+        <p:nvSpPr>
+          <p:cNvPr id="7" name="Regelwerk-Link"/>
+          <p:cNvSpPr/>
+          <p:nvPr/>
+        </p:nvSpPr>
+        <p:spPr>
+          <a:xfrm>
+            <a:off x="548640" y="5040000"/>
+            <a:ext cx="9592056" cy="274320"/>
+          </a:xfrm>
+          <a:prstGeom prst="rect">
+            <a:avLst/>
+          </a:prstGeom>
+          <a:noFill/>
+          <a:ln/>
+        </p:spPr>
+        <p:txBody>
+          <a:bodyPr wrap="square" lIns="0" tIns="0" rIns="0" bIns="0" rtlCol="0" anchor="t"/>
+          <a:lstStyle/>
+          <a:p>
+            <a:pPr indent="0" marL="0">
+              <a:buNone/>
+            </a:pPr>
+            <a:r>
+              <a:rPr lang="de-CH" sz="1000" dirty="0">
+                <a:solidFill>
+                  <a:srgbClr val="6B7480"/>
+                </a:solidFill>
+                <a:latin typeface="Goetheanum Schrift" pitchFamily="34" charset="0"/>
+                <a:ea typeface="Goetheanum Schrift" pitchFamily="34" charset="-122"/>
+                <a:cs typeface="Goetheanum Schrift" pitchFamily="34" charset="-120"/>
+              </a:rPr>
+              <a:t>Das ganze Regelwerk: </a:t>
+            </a:r>
+            <a:r>
+              <a:rPr lang="de-CH" sz="1000" dirty="0">
+                <a:solidFill>
+                  <a:srgbClr val="005EB8"/>
+                </a:solidFill>
+                <a:latin typeface="Goetheanum Schrift" pitchFamily="34" charset="0"/>
+                <a:ea typeface="Goetheanum Schrift" pitchFamily="34" charset="-122"/>
+                <a:cs typeface="Goetheanum Schrift" pitchFamily="34" charset="-120"/>
+                <a:hlinkClick r:id="rId2" invalidUrl="" action="" tgtFrame="" tooltip="" history="1" highlightClick="0" endSnd="0">
+                  <a:extLst>
+                    <a:ext uri="{A12FA001-AC4F-418D-AE19-62706E023703}">
+                      <ahyp:hlinkClr xmlns:ahyp="http://schemas.microsoft.com/office/drawing/2018/hyperlinkcolor" val="tx"/>
+                    </a:ext>
+                  </a:extLst>
+                </a:hlinkClick>
+              </a:rPr>
+              <a:t>werkzeuge.goetheanum.ch/typografie</a:t>
+            </a:r>
+          </a:p>
+        </p:txBody>
+      </p:sp>
+    </p:spTree>
+  </p:cSld>
+</p:sld>
+</file>
+
+<file path=ppt/slides/slide17.xml><?xml version="1.0" encoding="utf-8"?>
+<p:sld xmlns:a="http://schemas.openxmlformats.org/drawingml/2006/main" xmlns:r="http://schemas.openxmlformats.org/officeDocument/2006/relationships" xmlns:p="http://schemas.openxmlformats.org/presentationml/2006/main">
+  <p:cSld name="GOE Feintypografie 2">
+    <p:spTree>
+      <p:nvGrpSpPr>
+        <p:cNvPr id="1" name=""/>
+        <p:cNvGrpSpPr/>
+        <p:nvPr/>
+      </p:nvGrpSpPr>
+      <p:grpSpPr>
+        <a:xfrm>
+          <a:off x="0" y="0"/>
+          <a:ext cx="0" cy="0"/>
+          <a:chOff x="0" y="0"/>
+          <a:chExt cx="0" cy="0"/>
+        </a:xfrm>
+      </p:grpSpPr>
+      <p:sp>
+        <p:nvSpPr>
+          <p:cNvPr id="2" name="Kicker"/>
+          <p:cNvSpPr/>
+          <p:nvPr/>
+        </p:nvSpPr>
+        <p:spPr>
+          <a:xfrm>
+            <a:off x="548640" y="1143000"/>
+            <a:ext cx="4572000" cy="274320"/>
+          </a:xfrm>
+          <a:prstGeom prst="rect">
+            <a:avLst/>
+          </a:prstGeom>
+          <a:noFill/>
+          <a:ln/>
+        </p:spPr>
+        <p:txBody>
+          <a:bodyPr wrap="square" lIns="0" tIns="0" rIns="0" bIns="0" rtlCol="0" anchor="t"/>
+          <a:lstStyle/>
+          <a:p>
+            <a:pPr indent="0" marL="0">
+              <a:buNone/>
+            </a:pPr>
+            <a:r>
+              <a:rPr lang="de-CH" sz="1300" dirty="0">
+                <a:solidFill>
+                  <a:srgbClr val="005EB8"/>
+                </a:solidFill>
+                <a:latin typeface="Goetheanum Schrift" pitchFamily="34" charset="0"/>
+                <a:ea typeface="Goetheanum Schrift" pitchFamily="34" charset="-122"/>
+                <a:cs typeface="Goetheanum Schrift" pitchFamily="34" charset="-120"/>
+              </a:rPr>
+              <a:t>Vorlage</a:t>
+            </a:r>
+          </a:p>
+        </p:txBody>
+      </p:sp>
+      <p:sp>
+        <p:nvSpPr>
+          <p:cNvPr id="3" name="Titel"/>
+          <p:cNvSpPr/>
+          <p:nvPr/>
+        </p:nvSpPr>
+        <p:spPr>
+          <a:xfrm>
+            <a:off x="548640" y="1463040"/>
+            <a:ext cx="9592056" cy="594360"/>
+          </a:xfrm>
+          <a:prstGeom prst="rect">
+            <a:avLst/>
+          </a:prstGeom>
+          <a:noFill/>
+          <a:ln/>
+        </p:spPr>
+        <p:txBody>
+          <a:bodyPr wrap="square" lIns="0" tIns="0" rIns="0" bIns="0" rtlCol="0" anchor="t"/>
+          <a:lstStyle/>
+          <a:p>
+            <a:pPr indent="0" marL="0">
+              <a:buNone/>
+            </a:pPr>
+            <a:r>
+              <a:rPr lang="de-CH" sz="2600" dirty="0">
+                <a:solidFill>
+                  <a:srgbClr val="1A1A1A"/>
+                </a:solidFill>
+                <a:latin typeface="Goetheanum Schrift Deutlich" pitchFamily="34" charset="0"/>
+                <a:ea typeface="Goetheanum Schrift Deutlich" pitchFamily="34" charset="-122"/>
+                <a:cs typeface="Goetheanum Schrift Deutlich" pitchFamily="34" charset="-120"/>
+              </a:rPr>
+              <a:t>Noch feinere Zeichen</a:t>
+            </a:r>
+          </a:p>
+        </p:txBody>
+      </p:sp>
+      <p:sp>
+        <p:nvSpPr>
+          <p:cNvPr id="4" name="Lede"/>
+          <p:cNvSpPr/>
+          <p:nvPr/>
+        </p:nvSpPr>
+        <p:spPr>
+          <a:xfrm>
+            <a:off x="548640" y="2286000"/>
+            <a:ext cx="9592056" cy="320040"/>
+          </a:xfrm>
+          <a:prstGeom prst="rect">
+            <a:avLst/>
+          </a:prstGeom>
+          <a:noFill/>
+          <a:ln/>
+        </p:spPr>
+        <p:txBody>
+          <a:bodyPr wrap="square" lIns="0" tIns="0" rIns="0" bIns="0" rtlCol="0" anchor="t"/>
+          <a:lstStyle/>
+          <a:p>
+            <a:pPr indent="0" marL="0">
+              <a:buNone/>
+            </a:pPr>
+            <a:r>
+              <a:rPr lang="de-CH" sz="1300" dirty="0">
+                <a:solidFill>
+                  <a:srgbClr val="6B7480"/>
+                </a:solidFill>
+                <a:latin typeface="Goetheanum Schrift" pitchFamily="34" charset="0"/>
+                <a:ea typeface="Goetheanum Schrift" pitchFamily="34" charset="-122"/>
+                <a:cs typeface="Goetheanum Schrift" pitchFamily="34" charset="-120"/>
+              </a:rPr>
+              <a:t>Striche mit Namen, Punkte mit Mass – kleine Unterschiede, grosse Ruhe.</a:t>
+            </a:r>
+          </a:p>
+        </p:txBody>
+      </p:sp>
+      <p:sp>
+        <p:nvSpPr>
+          <p:cNvPr id="5" name="BeispieleLinks"/>
+          <p:cNvSpPr/>
+          <p:nvPr/>
+        </p:nvSpPr>
+        <p:spPr>
+          <a:xfrm>
+            <a:off x="548640" y="3060000"/>
+            <a:ext cx="4680000" cy="3960000"/>
+          </a:xfrm>
+          <a:prstGeom prst="rect">
+            <a:avLst/>
+          </a:prstGeom>
+          <a:noFill/>
+          <a:ln/>
+        </p:spPr>
+        <p:txBody>
+          <a:bodyPr wrap="square" lIns="0" tIns="0" rIns="0" bIns="0" rtlCol="0" anchor="t"/>
+          <a:lstStyle/>
+          <a:p>
+            <a:pPr indent="0" marL="0">
+              <a:buNone/>
+            </a:pPr>
+            <a:r>
+              <a:rPr lang="de-CH" sz="2400" dirty="0">
+                <a:solidFill>
+                  <a:srgbClr val="1A1A1A"/>
+                </a:solidFill>
+                <a:latin typeface="Goetheanum Schrift" pitchFamily="34" charset="0"/>
+                <a:ea typeface="Goetheanum Schrift" pitchFamily="34" charset="-122"/>
+                <a:cs typeface="Goetheanum Schrift" pitchFamily="34" charset="-120"/>
+              </a:rPr>
+              <a:t>und so weiter …</a:t>
+            </a:r>
+          </a:p>
+          <a:p>
+            <a:pPr indent="0" marL="0">
+              <a:spcBef>
+                <a:spcPts val="200"/>
+              </a:spcBef>
+              <a:buNone/>
+            </a:pPr>
+            <a:r>
+              <a:rPr lang="de-CH" sz="1000" dirty="0">
+                <a:solidFill>
+                  <a:srgbClr val="6B7480"/>
+                </a:solidFill>
+                <a:latin typeface="Goetheanum Schrift" pitchFamily="34" charset="0"/>
+                <a:ea typeface="Goetheanum Schrift" pitchFamily="34" charset="-122"/>
+                <a:cs typeface="Goetheanum Schrift" pitchFamily="34" charset="-120"/>
+              </a:rPr>
+              <a:t>Auslassung: ein Zeichen …, nicht drei Punkte</a:t>
+            </a:r>
+          </a:p>
+          <a:p>
+            <a:pPr indent="0" marL="0">
+              <a:spcBef>
+                <a:spcPts val="2000"/>
+              </a:spcBef>
+              <a:buNone/>
+            </a:pPr>
+            <a:r>
+              <a:rPr lang="de-CH" sz="2400" dirty="0">
+                <a:solidFill>
+                  <a:srgbClr val="1A1A1A"/>
+                </a:solidFill>
+                <a:latin typeface="Goetheanum Schrift" pitchFamily="34" charset="0"/>
+                <a:ea typeface="Goetheanum Schrift" pitchFamily="34" charset="-122"/>
+                <a:cs typeface="Goetheanum Schrift" pitchFamily="34" charset="-120"/>
+              </a:rPr>
+              <a:t>Ja – oder Nein?</a:t>
+            </a:r>
+          </a:p>
+          <a:p>
+            <a:pPr indent="0" marL="0">
+              <a:spcBef>
+                <a:spcPts val="200"/>
+              </a:spcBef>
+              <a:buNone/>
+            </a:pPr>
+            <a:r>
+              <a:rPr lang="de-CH" sz="1000" dirty="0">
+                <a:solidFill>
+                  <a:srgbClr val="6B7480"/>
+                </a:solidFill>
+                <a:latin typeface="Goetheanum Schrift" pitchFamily="34" charset="0"/>
+                <a:ea typeface="Goetheanum Schrift" pitchFamily="34" charset="-122"/>
+                <a:cs typeface="Goetheanum Schrift" pitchFamily="34" charset="-120"/>
+              </a:rPr>
+              <a:t>Gedankenstrich: Halbgeviert – mit Spatien</a:t>
+            </a:r>
+          </a:p>
+          <a:p>
+            <a:pPr indent="0" marL="0">
+              <a:spcBef>
+                <a:spcPts val="2000"/>
+              </a:spcBef>
+              <a:buNone/>
+            </a:pPr>
+            <a:r>
+              <a:rPr lang="de-CH" sz="2400" dirty="0">
+                <a:solidFill>
+                  <a:srgbClr val="1A1A1A"/>
+                </a:solidFill>
+                <a:latin typeface="Goetheanum Schrift" pitchFamily="34" charset="0"/>
+                <a:ea typeface="Goetheanum Schrift" pitchFamily="34" charset="-122"/>
+                <a:cs typeface="Goetheanum Schrift" pitchFamily="34" charset="-120"/>
+              </a:rPr>
+              <a:t>9–17 Uhr</a:t>
+            </a:r>
+          </a:p>
+          <a:p>
+            <a:pPr indent="0" marL="0">
+              <a:spcBef>
+                <a:spcPts val="200"/>
+              </a:spcBef>
+              <a:buNone/>
+            </a:pPr>
+            <a:r>
+              <a:rPr lang="de-CH" sz="1000" dirty="0">
+                <a:solidFill>
+                  <a:srgbClr val="6B7480"/>
+                </a:solidFill>
+                <a:latin typeface="Goetheanum Schrift" pitchFamily="34" charset="0"/>
+                <a:ea typeface="Goetheanum Schrift" pitchFamily="34" charset="-122"/>
+                <a:cs typeface="Goetheanum Schrift" pitchFamily="34" charset="-120"/>
+              </a:rPr>
+              <a:t>Bis-Strich: Halbgeviert, ohne Spatien</a:t>
+            </a:r>
+          </a:p>
+        </p:txBody>
+      </p:sp>
+      <p:sp>
+        <p:nvSpPr>
+          <p:cNvPr id="6" name="BeispieleRechts"/>
+          <p:cNvSpPr/>
+          <p:nvPr/>
+        </p:nvSpPr>
+        <p:spPr>
+          <a:xfrm>
+            <a:off x="5688640" y="3060000"/>
+            <a:ext cx="4680000" cy="3960000"/>
+          </a:xfrm>
+          <a:prstGeom prst="rect">
+            <a:avLst/>
+          </a:prstGeom>
+          <a:noFill/>
+          <a:ln/>
+        </p:spPr>
+        <p:txBody>
+          <a:bodyPr wrap="square" lIns="0" tIns="0" rIns="0" bIns="0" rtlCol="0" anchor="t"/>
+          <a:lstStyle/>
+          <a:p>
+            <a:pPr indent="0" marL="0">
+              <a:buNone/>
+            </a:pPr>
+            <a:r>
+              <a:rPr lang="de-CH" sz="2400" dirty="0">
+                <a:solidFill>
+                  <a:srgbClr val="1A1A1A"/>
+                </a:solidFill>
+                <a:latin typeface="Goetheanum Schrift" pitchFamily="34" charset="0"/>
+                <a:ea typeface="Goetheanum Schrift" pitchFamily="34" charset="-122"/>
+                <a:cs typeface="Goetheanum Schrift" pitchFamily="34" charset="-120"/>
+              </a:rPr>
+              <a:t>z. B. sonntags</a:t>
+            </a:r>
+          </a:p>
+          <a:p>
+            <a:pPr indent="0" marL="0">
+              <a:spcBef>
+                <a:spcPts val="200"/>
+              </a:spcBef>
+              <a:buNone/>
+            </a:pPr>
+            <a:r>
+              <a:rPr lang="de-CH" sz="1000" dirty="0">
+                <a:solidFill>
+                  <a:srgbClr val="6B7480"/>
+                </a:solidFill>
+                <a:latin typeface="Goetheanum Schrift" pitchFamily="34" charset="0"/>
+                <a:ea typeface="Goetheanum Schrift" pitchFamily="34" charset="-122"/>
+                <a:cs typeface="Goetheanum Schrift" pitchFamily="34" charset="-120"/>
+              </a:rPr>
+              <a:t>schmales geschütztes Leerzeichen, auch in Abkürzungen</a:t>
+            </a:r>
+          </a:p>
+          <a:p>
+            <a:pPr indent="0" marL="0">
+              <a:spcBef>
+                <a:spcPts val="2000"/>
+              </a:spcBef>
+              <a:buNone/>
+            </a:pPr>
+            <a:r>
+              <a:rPr lang="de-CH" sz="2400" dirty="0">
+                <a:solidFill>
+                  <a:srgbClr val="1A1A1A"/>
+                </a:solidFill>
+                <a:latin typeface="Goetheanum Schrift" pitchFamily="34" charset="0"/>
+                <a:ea typeface="Goetheanum Schrift" pitchFamily="34" charset="-122"/>
+                <a:cs typeface="Goetheanum Schrift" pitchFamily="34" charset="-120"/>
+              </a:rPr>
+              <a:t>Grösse</a:t>
+            </a:r>
+          </a:p>
+          <a:p>
+            <a:pPr indent="0" marL="0">
+              <a:spcBef>
+                <a:spcPts val="200"/>
+              </a:spcBef>
+              <a:buNone/>
+            </a:pPr>
+            <a:r>
+              <a:rPr lang="de-CH" sz="1000" dirty="0">
+                <a:solidFill>
+                  <a:srgbClr val="6B7480"/>
+                </a:solidFill>
+                <a:latin typeface="Goetheanum Schrift" pitchFamily="34" charset="0"/>
+                <a:ea typeface="Goetheanum Schrift" pitchFamily="34" charset="-122"/>
+                <a:cs typeface="Goetheanum Schrift" pitchFamily="34" charset="-120"/>
+              </a:rPr>
+              <a:t>Schweizer Schreibung: ss statt ß</a:t>
+            </a:r>
+          </a:p>
+          <a:p>
+            <a:pPr indent="0" marL="0">
+              <a:spcBef>
+                <a:spcPts val="2000"/>
+              </a:spcBef>
+              <a:buNone/>
+            </a:pPr>
+            <a:r>
+              <a:rPr lang="de-CH" sz="2400" dirty="0">
+                <a:solidFill>
+                  <a:srgbClr val="1A1A1A"/>
+                </a:solidFill>
+                <a:latin typeface="Goetheanum Schrift" pitchFamily="34" charset="0"/>
+                <a:ea typeface="Goetheanum Schrift" pitchFamily="34" charset="-122"/>
+                <a:cs typeface="Goetheanum Schrift" pitchFamily="34" charset="-120"/>
+              </a:rPr>
+              <a:t>Silbentrennung</a:t>
+            </a:r>
+          </a:p>
+          <a:p>
+            <a:pPr indent="0" marL="0">
+              <a:spcBef>
+                <a:spcPts val="200"/>
+              </a:spcBef>
+              <a:buNone/>
+            </a:pPr>
+            <a:r>
+              <a:rPr lang="de-CH" sz="1000" dirty="0">
+                <a:solidFill>
+                  <a:srgbClr val="6B7480"/>
+                </a:solidFill>
+                <a:latin typeface="Goetheanum Schrift" pitchFamily="34" charset="0"/>
+                <a:ea typeface="Goetheanum Schrift" pitchFamily="34" charset="-122"/>
+                <a:cs typeface="Goetheanum Schrift" pitchFamily="34" charset="-120"/>
+              </a:rPr>
+              <a:t>aktiv gesetzt – für einen ruhigen Rand</a:t>
+            </a:r>
+          </a:p>
+        </p:txBody>
+      </p:sp>
+      <p:sp>
+        <p:nvSpPr>
+          <p:cNvPr id="7" name="Regelwerk-Link"/>
+          <p:cNvSpPr/>
+          <p:nvPr/>
+        </p:nvSpPr>
+        <p:spPr>
+          <a:xfrm>
+            <a:off x="548640" y="5040000"/>
+            <a:ext cx="9592056" cy="274320"/>
+          </a:xfrm>
+          <a:prstGeom prst="rect">
+            <a:avLst/>
+          </a:prstGeom>
+          <a:noFill/>
+          <a:ln/>
+        </p:spPr>
+        <p:txBody>
+          <a:bodyPr wrap="square" lIns="0" tIns="0" rIns="0" bIns="0" rtlCol="0" anchor="t"/>
+          <a:lstStyle/>
+          <a:p>
+            <a:pPr indent="0" marL="0">
+              <a:buNone/>
+            </a:pPr>
+            <a:r>
+              <a:rPr lang="de-CH" sz="1000" dirty="0">
+                <a:solidFill>
+                  <a:srgbClr val="6B7480"/>
+                </a:solidFill>
+                <a:latin typeface="Goetheanum Schrift" pitchFamily="34" charset="0"/>
+                <a:ea typeface="Goetheanum Schrift" pitchFamily="34" charset="-122"/>
+                <a:cs typeface="Goetheanum Schrift" pitchFamily="34" charset="-120"/>
+              </a:rPr>
+              <a:t>Das ganze Regelwerk: </a:t>
+            </a:r>
+            <a:r>
+              <a:rPr lang="de-CH" sz="1000" dirty="0">
+                <a:solidFill>
+                  <a:srgbClr val="005EB8"/>
+                </a:solidFill>
+                <a:latin typeface="Goetheanum Schrift" pitchFamily="34" charset="0"/>
+                <a:ea typeface="Goetheanum Schrift" pitchFamily="34" charset="-122"/>
+                <a:cs typeface="Goetheanum Schrift" pitchFamily="34" charset="-120"/>
+                <a:hlinkClick r:id="rId2" invalidUrl="" action="" tgtFrame="" tooltip="" history="1" highlightClick="0" endSnd="0">
+                  <a:extLst>
+                    <a:ext uri="{A12FA001-AC4F-418D-AE19-62706E023703}">
+                      <ahyp:hlinkClr xmlns:ahyp="http://schemas.microsoft.com/office/drawing/2018/hyperlinkcolor" val="tx"/>
+                    </a:ext>
+                  </a:extLst>
+                </a:hlinkClick>
+              </a:rPr>
+              <a:t>werkzeuge.goetheanum.ch/typografie</a:t>
+            </a:r>
+          </a:p>
+        </p:txBody>
+      </p:sp>
+    </p:spTree>
+  </p:cSld>
+</p:sld>
+</file>
+
 <file path=ppt/slides/slide2.xml><?xml version="1.0" encoding="utf-8"?>
 <p:sld xmlns:a="http://schemas.openxmlformats.org/drawingml/2006/main" xmlns:r="http://schemas.openxmlformats.org/officeDocument/2006/relationships" xmlns:p="http://schemas.openxmlformats.org/presentationml/2006/main">
   <p:cSld name="Slide 2">
@@ -8448,6 +9366,91 @@
               <a:t>2</a:t>
             </a:fld>
             <a:endParaRPr lang="en-US"/>
+          </a:p>
+        </p:txBody>
+      </p:sp>
+      <p:sp>
+        <p:nvSpPr>
+          <p:cNvPr id="26" name="Guetesiegel"/>
+          <p:cNvSpPr/>
+          <p:nvPr/>
+        </p:nvSpPr>
+        <p:spPr>
+          <a:xfrm>
+            <a:off x="6948000" y="5148000"/>
+            <a:ext cx="3204000" cy="1152000"/>
+          </a:xfrm>
+          <a:prstGeom prst="rect">
+            <a:avLst/>
+          </a:prstGeom>
+          <a:noFill/>
+          <a:ln/>
+        </p:spPr>
+        <p:txBody>
+          <a:bodyPr wrap="square" lIns="0" tIns="0" rIns="0" bIns="0" rtlCol="0" anchor="t"/>
+          <a:lstStyle/>
+          <a:p>
+            <a:pPr indent="0" marL="0">
+              <a:lnSpc>
+                <a:spcPct val="118000"/>
+              </a:lnSpc>
+              <a:buNone/>
+            </a:pPr>
+            <a:r>
+              <a:rPr lang="de-CH" sz="900" dirty="0">
+                <a:solidFill>
+                  <a:srgbClr val="005EB8"/>
+                </a:solidFill>
+                <a:latin typeface="Goetheanum Schrift" pitchFamily="34" charset="0"/>
+                <a:ea typeface="Goetheanum Schrift" pitchFamily="34" charset="-122"/>
+                <a:cs typeface="Goetheanum Schrift" pitchFamily="34" charset="-120"/>
+              </a:rPr>
+              <a:t>Gütesiegel</a:t>
+            </a:r>
+          </a:p>
+          <a:p>
+            <a:pPr indent="0" marL="0">
+              <a:lnSpc>
+                <a:spcPct val="118000"/>
+              </a:lnSpc>
+              <a:spcBef>
+                <a:spcPts val="300"/>
+              </a:spcBef>
+              <a:buNone/>
+            </a:pPr>
+            <a:r>
+              <a:rPr lang="de-CH" sz="900" dirty="0">
+                <a:solidFill>
+                  <a:srgbClr val="6B7480"/>
+                </a:solidFill>
+                <a:latin typeface="Goetheanum Schrift" pitchFamily="34" charset="0"/>
+                <a:ea typeface="Goetheanum Schrift" pitchFamily="34" charset="-122"/>
+                <a:cs typeface="Goetheanum Schrift" pitchFamily="34" charset="-120"/>
+              </a:rPr>
+              <a:t>Gesichert: Layout, Hausfarben, Schrift, geprüfte Kontraste – barrierefrei.</a:t>
+            </a:r>
+          </a:p>
+          <a:p>
+            <a:pPr indent="0" marL="0">
+              <a:lnSpc>
+                <a:spcPct val="118000"/>
+              </a:lnSpc>
+              <a:spcBef>
+                <a:spcPts val="300"/>
+              </a:spcBef>
+              <a:buNone/>
+            </a:pPr>
+            <a:r>
+              <a:rPr lang="de-CH" sz="900" dirty="0">
+                <a:solidFill>
+                  <a:srgbClr val="6B7480"/>
+                </a:solidFill>
+                <a:latin typeface="Goetheanum Schrift" pitchFamily="34" charset="0"/>
+                <a:ea typeface="Goetheanum Schrift" pitchFamily="34" charset="-122"/>
+                <a:cs typeface="Goetheanum Schrift" pitchFamily="34" charset="-120"/>
+              </a:rPr>
+              <a:t>Der Feinschliff ist Goodwill – nutze die gemeinsame Sprache und entwickle sie mit.</a:t>
+            </a:r>
           </a:p>
         </p:txBody>
       </p:sp>
@@ -11849,7 +12852,7 @@
                 <a:ea typeface="Goetheanum Schrift" pitchFamily="34" charset="-122"/>
                 <a:cs typeface="Goetheanum Schrift" pitchFamily="34" charset="-120"/>
               </a:rPr>
-              <a:t>betont allein durch die Fette.</a:t>
+              <a:t>betont allein durch die Fette – ein Merkmal genügt (Einfachauszeichnung).</a:t>
             </a:r>
             <a:endParaRPr lang="en-US" sz="1300" dirty="0"/>
           </a:p>
@@ -12226,7 +13229,7 @@
                 <a:ea typeface="Goetheanum Schrift" pitchFamily="34" charset="-122"/>
                 <a:cs typeface="Goetheanum Schrift" pitchFamily="34" charset="-120"/>
               </a:rPr>
-              <a:t>Zwischentitel in Laut 13,</a:t>
+              <a:t>Zwischentitel in Deutlich 13,</a:t>
             </a:r>
             <a:endParaRPr lang="en-US" sz="1300" dirty="0"/>
           </a:p>
@@ -12693,7 +13696,7 @@
                 <a:ea typeface="Goetheanum Schrift" pitchFamily="34" charset="-122"/>
                 <a:cs typeface="Goetheanum Schrift" pitchFamily="34" charset="-120"/>
               </a:rPr>
-              <a:t>Der Text behält seine Spaltenbreite</a:t>
+              <a:t>Der Text behält seine Spaltenbreite – rund 62 Zeichen –</a:t>
             </a:r>
             <a:endParaRPr lang="en-US" sz="1300" dirty="0"/>
           </a:p>

</xml_diff>